<commit_message>
Added my sectors to the pp and will add a video tomorrow before the presentation.
</commit_message>
<xml_diff>
--- a/DraftSlides/COCKY INVESTMENTS, INCv7.pptx
+++ b/DraftSlides/COCKY INVESTMENTS, INCv7.pptx
@@ -230,7 +230,7 @@
           <a:p>
             <a:fld id="{7D038C9C-4B69-864E-9EEE-DFA43CC144D2}" type="datetimeFigureOut">
               <a:rPr lang="en-US" smtClean="0"/>
-              <a:t>4/23/2026</a:t>
+              <a:t>4/24/2026</a:t>
             </a:fld>
             <a:endParaRPr lang="en-US"/>
           </a:p>
@@ -407,7 +407,7 @@
           <a:p>
             <a:fld id="{41D9A61E-B1D6-C34D-A321-B3E90F6DE630}" type="datetimeFigureOut">
               <a:rPr lang="en-US" smtClean="0"/>
-              <a:t>4/23/2026</a:t>
+              <a:t>4/24/2026</a:t>
             </a:fld>
             <a:endParaRPr lang="en-US"/>
           </a:p>
@@ -4236,10 +4236,10 @@
       </p:sp>
       <p:pic>
         <p:nvPicPr>
-          <p:cNvPr id="4" name="Picture 3">
-            <a:extLst>
-              <a:ext uri="{FF2B5EF4-FFF2-40B4-BE49-F238E27FC236}">
-                <a16:creationId xmlns:a16="http://schemas.microsoft.com/office/drawing/2014/main" id="{41BEB70F-070A-4F01-89FB-79C897B42B81}"/>
+          <p:cNvPr id="11" name="Picture 10">
+            <a:extLst>
+              <a:ext uri="{FF2B5EF4-FFF2-40B4-BE49-F238E27FC236}">
+                <a16:creationId xmlns:a16="http://schemas.microsoft.com/office/drawing/2014/main" id="{CDF32B83-4D75-4B4E-9333-67E8D8C4F7B1}"/>
               </a:ext>
             </a:extLst>
           </p:cNvPr>
@@ -4256,14 +4256,132 @@
         </p:blipFill>
         <p:spPr>
           <a:xfrm>
-            <a:off x="880420" y="1935350"/>
-            <a:ext cx="10431160" cy="2987299"/>
+            <a:off x="722461" y="1311295"/>
+            <a:ext cx="6087612" cy="2598230"/>
           </a:xfrm>
           <a:prstGeom prst="rect">
             <a:avLst/>
           </a:prstGeom>
         </p:spPr>
       </p:pic>
+      <p:pic>
+        <p:nvPicPr>
+          <p:cNvPr id="17" name="Picture 16">
+            <a:extLst>
+              <a:ext uri="{FF2B5EF4-FFF2-40B4-BE49-F238E27FC236}">
+                <a16:creationId xmlns:a16="http://schemas.microsoft.com/office/drawing/2014/main" id="{E4A0566C-8B89-4712-E7D0-793350BCD13F}"/>
+              </a:ext>
+            </a:extLst>
+          </p:cNvPr>
+          <p:cNvPicPr>
+            <a:picLocks noChangeAspect="1"/>
+          </p:cNvPicPr>
+          <p:nvPr/>
+        </p:nvPicPr>
+        <p:blipFill>
+          <a:blip r:embed="rId3"/>
+          <a:stretch>
+            <a:fillRect/>
+          </a:stretch>
+        </p:blipFill>
+        <p:spPr>
+          <a:xfrm>
+            <a:off x="860233" y="3909525"/>
+            <a:ext cx="5949840" cy="2508156"/>
+          </a:xfrm>
+          <a:prstGeom prst="rect">
+            <a:avLst/>
+          </a:prstGeom>
+        </p:spPr>
+      </p:pic>
+      <p:sp>
+        <p:nvSpPr>
+          <p:cNvPr id="19" name="TextBox 18">
+            <a:extLst>
+              <a:ext uri="{FF2B5EF4-FFF2-40B4-BE49-F238E27FC236}">
+                <a16:creationId xmlns:a16="http://schemas.microsoft.com/office/drawing/2014/main" id="{577F6794-F236-C2C5-35E2-092541F35D55}"/>
+              </a:ext>
+            </a:extLst>
+          </p:cNvPr>
+          <p:cNvSpPr txBox="1"/>
+          <p:nvPr/>
+        </p:nvSpPr>
+        <p:spPr>
+          <a:xfrm>
+            <a:off x="6961149" y="1687080"/>
+            <a:ext cx="4508390" cy="923330"/>
+          </a:xfrm>
+          <a:prstGeom prst="rect">
+            <a:avLst/>
+          </a:prstGeom>
+          <a:noFill/>
+        </p:spPr>
+        <p:txBody>
+          <a:bodyPr wrap="square" rtlCol="0">
+            <a:spAutoFit/>
+          </a:bodyPr>
+          <a:lstStyle/>
+          <a:p>
+            <a:r>
+              <a:rPr lang="en-US" dirty="0"/>
+              <a:t>Overview of the Top 20 stock options showing primarily gradual payouts with a few high-yield outliers.</a:t>
+            </a:r>
+          </a:p>
+        </p:txBody>
+      </p:sp>
+      <p:sp>
+        <p:nvSpPr>
+          <p:cNvPr id="20" name="TextBox 19">
+            <a:extLst>
+              <a:ext uri="{FF2B5EF4-FFF2-40B4-BE49-F238E27FC236}">
+                <a16:creationId xmlns:a16="http://schemas.microsoft.com/office/drawing/2014/main" id="{1EC1FB88-448A-4218-80EA-7E18427D50A5}"/>
+              </a:ext>
+            </a:extLst>
+          </p:cNvPr>
+          <p:cNvSpPr txBox="1"/>
+          <p:nvPr/>
+        </p:nvSpPr>
+        <p:spPr>
+          <a:xfrm>
+            <a:off x="6961149" y="4159552"/>
+            <a:ext cx="4694875" cy="1200329"/>
+          </a:xfrm>
+          <a:prstGeom prst="rect">
+            <a:avLst/>
+          </a:prstGeom>
+          <a:noFill/>
+        </p:spPr>
+        <p:txBody>
+          <a:bodyPr wrap="none" rtlCol="0">
+            <a:spAutoFit/>
+          </a:bodyPr>
+          <a:lstStyle/>
+          <a:p>
+            <a:r>
+              <a:rPr lang="en-US" dirty="0"/>
+              <a:t>Year-Over-Year prices at the end of the year</a:t>
+            </a:r>
+          </a:p>
+          <a:p>
+            <a:r>
+              <a:rPr lang="en-US" dirty="0"/>
+              <a:t>show cyclical behaviors among tickers</a:t>
+            </a:r>
+          </a:p>
+          <a:p>
+            <a:r>
+              <a:rPr lang="en-US" dirty="0"/>
+              <a:t>alongside a steady increase among these </a:t>
+            </a:r>
+          </a:p>
+          <a:p>
+            <a:r>
+              <a:rPr lang="en-US" dirty="0"/>
+              <a:t>earners.</a:t>
+            </a:r>
+          </a:p>
+        </p:txBody>
+      </p:sp>
     </p:spTree>
     <p:extLst>
       <p:ext uri="{BB962C8B-B14F-4D97-AF65-F5344CB8AC3E}">

</xml_diff>